<commit_message>
insert "No Crystal Ball" slide into the pptx at position 4
Matches the markdown addition - inserted after the Disclaimer slide,
before The Dark Factory Concept, using the same Content layout and
formatting as the rest of the deck. Includes speaker notes.

Co-Authored-By: Claude Sonnet 5 <noreply@anthropic.com>
</commit_message>
<xml_diff>
--- a/UNT/dark_factory.pptx
+++ b/UNT/dark_factory.pptx
@@ -11,6 +11,7 @@
     <p:sldId id="256" r:id="rId2"/>
     <p:sldId id="282" r:id="rId3"/>
     <p:sldId id="269" r:id="rId4"/>
+    <p:sldId id="337" r:id="rId65"/>
     <p:sldId id="336" r:id="rId5"/>
     <p:sldId id="284" r:id="rId6"/>
     <p:sldId id="285" r:id="rId7"/>
@@ -4709,6 +4710,81 @@
 </p:notes>
 </file>
 
+<file path=ppt/notesSlides/notesSlide57.xml><?xml version="1.0" encoding="utf-8"?>
+<p:notes xmlns:a="http://schemas.openxmlformats.org/drawingml/2006/main" xmlns:p="http://schemas.openxmlformats.org/presentationml/2006/main" xmlns:r="http://schemas.openxmlformats.org/officeDocument/2006/relationships">
+  <p:cSld>
+    <p:spTree>
+      <p:nvGrpSpPr>
+        <p:cNvPr id="1" name=""/>
+        <p:cNvGrpSpPr/>
+        <p:nvPr/>
+      </p:nvGrpSpPr>
+      <p:grpSpPr>
+        <a:xfrm>
+          <a:off x="0" y="0"/>
+          <a:ext cx="0" cy="0"/>
+          <a:chOff x="0" y="0"/>
+          <a:chExt cx="0" cy="0"/>
+        </a:xfrm>
+      </p:grpSpPr>
+      <p:sp>
+        <p:nvSpPr>
+          <p:cNvPr id="2" name="Slide Image Placeholder 1"/>
+          <p:cNvSpPr>
+            <a:spLocks noGrp="1"/>
+          </p:cNvSpPr>
+          <p:nvPr>
+            <p:ph type="sldImg" idx="2"/>
+          </p:nvPr>
+        </p:nvSpPr>
+        <p:spPr/>
+      </p:sp>
+      <p:sp>
+        <p:nvSpPr>
+          <p:cNvPr id="3" name="Notes Placeholder 2"/>
+          <p:cNvSpPr>
+            <a:spLocks noGrp="1"/>
+          </p:cNvSpPr>
+          <p:nvPr>
+            <p:ph type="body" idx="3" sz="quarter"/>
+          </p:nvPr>
+        </p:nvSpPr>
+        <p:spPr/>
+        <p:txBody>
+          <a:bodyPr/>
+          <a:lstStyle/>
+          <a:p>
+            <a:r>
+              <a:t>Set expectations up front: no predictions here, just current state.</a:t>
+            </a:r>
+          </a:p>
+          <a:p>
+            <a:r>
+              <a:t>Everything after this is descriptive, not prescriptive of the future.</a:t>
+            </a:r>
+          </a:p>
+        </p:txBody>
+      </p:sp>
+      <p:sp>
+        <p:nvSpPr>
+          <p:cNvPr id="4" name="Slide Number Placeholder 3"/>
+          <p:cNvSpPr>
+            <a:spLocks noGrp="1"/>
+          </p:cNvSpPr>
+          <p:nvPr>
+            <p:ph type="sldNum" idx="5" sz="quarter"/>
+          </p:nvPr>
+        </p:nvSpPr>
+        <p:spPr/>
+      </p:sp>
+    </p:spTree>
+  </p:cSld>
+  <p:clrMapOvr>
+    <a:masterClrMapping/>
+  </p:clrMapOvr>
+</p:notes>
+</file>
+
 <file path=ppt/notesSlides/notesSlide6.xml><?xml version="1.0" encoding="utf-8"?>
 <p:notes xmlns:a="http://schemas.openxmlformats.org/drawingml/2006/main" xmlns:r="http://schemas.openxmlformats.org/officeDocument/2006/relationships" xmlns:p="http://schemas.openxmlformats.org/presentationml/2006/main">
   <p:cSld>
@@ -13295,6 +13371,81 @@
         <p14:creationId xmlns:p14="http://schemas.microsoft.com/office/powerpoint/2010/main" val="2161850691"/>
       </p:ext>
     </p:extLst>
+  </p:cSld>
+  <p:clrMapOvr>
+    <a:masterClrMapping/>
+  </p:clrMapOvr>
+</p:sld>
+</file>
+
+<file path=ppt/slides/slide57.xml><?xml version="1.0" encoding="utf-8"?>
+<p:sld xmlns:a="http://schemas.openxmlformats.org/drawingml/2006/main" xmlns:p="http://schemas.openxmlformats.org/presentationml/2006/main" xmlns:r="http://schemas.openxmlformats.org/officeDocument/2006/relationships">
+  <p:cSld>
+    <p:spTree>
+      <p:nvGrpSpPr>
+        <p:cNvPr id="1" name=""/>
+        <p:cNvGrpSpPr/>
+        <p:nvPr/>
+      </p:nvGrpSpPr>
+      <p:grpSpPr/>
+      <p:sp>
+        <p:nvSpPr>
+          <p:cNvPr id="2" name="Text Placeholder 1"/>
+          <p:cNvSpPr>
+            <a:spLocks noGrp="1"/>
+          </p:cNvSpPr>
+          <p:nvPr>
+            <p:ph type="body" idx="11" sz="quarter"/>
+          </p:nvPr>
+        </p:nvSpPr>
+        <p:spPr/>
+        <p:txBody>
+          <a:bodyPr/>
+          <a:lstStyle/>
+          <a:p>
+            <a:r>
+              <a:t>Not a fortune teller — no crystal ball here</a:t>
+            </a:r>
+          </a:p>
+          <a:p>
+            <a:r>
+              <a:t>This talk shows what's happening now, not what's coming next</a:t>
+            </a:r>
+          </a:p>
+          <a:p>
+            <a:r>
+              <a:t>Every stat and framework is a snapshot, not a prophecy</a:t>
+            </a:r>
+          </a:p>
+          <a:p>
+            <a:r>
+              <a:t>“Why now” means as of today, not a forecast</a:t>
+            </a:r>
+          </a:p>
+        </p:txBody>
+      </p:sp>
+      <p:sp>
+        <p:nvSpPr>
+          <p:cNvPr id="3" name="Title 2"/>
+          <p:cNvSpPr>
+            <a:spLocks noGrp="1"/>
+          </p:cNvSpPr>
+          <p:nvPr>
+            <p:ph type="title"/>
+          </p:nvPr>
+        </p:nvSpPr>
+        <p:spPr/>
+        <p:txBody>
+          <a:bodyPr/>
+          <a:lstStyle/>
+          <a:p>
+            <a:r>
+              <a:t>No Crystal Ball</a:t>
+            </a:r>
+          </a:p>
+        </p:txBody>
+      </p:sp>
+    </p:spTree>
   </p:cSld>
   <p:clrMapOvr>
     <a:masterClrMapping/>

</xml_diff>